<commit_message>
creacion resumen general v2
</commit_message>
<xml_diff>
--- a/2.Texto/Imag/arquitectura_alto_nivel.pptx
+++ b/2.Texto/Imag/arquitectura_alto_nivel.pptx
@@ -660,79 +660,55 @@
       </p:grpSpPr>
       <p:sp>
         <p:nvSpPr>
-          <p:cNvPr id="2" name="Text 0"/>
+          <p:cNvPr id="89" name="Rectangle: Rounded Corners 88">
+            <a:extLst>
+              <a:ext uri="{FF2B5EF4-FFF2-40B4-BE49-F238E27FC236}">
+                <a16:creationId xmlns:a16="http://schemas.microsoft.com/office/drawing/2014/main" id="{722FE280-0E8F-1036-EE60-21DD9999EA6A}"/>
+              </a:ext>
+            </a:extLst>
+          </p:cNvPr>
           <p:cNvSpPr/>
           <p:nvPr/>
         </p:nvSpPr>
         <p:spPr>
           <a:xfrm>
-            <a:off x="137160" y="32419"/>
-            <a:ext cx="4214901" cy="310896"/>
-          </a:xfrm>
-          <a:prstGeom prst="rect">
+            <a:off x="1559190" y="4728418"/>
+            <a:ext cx="6157888" cy="380094"/>
+          </a:xfrm>
+          <a:prstGeom prst="roundRect">
             <a:avLst/>
           </a:prstGeom>
-          <a:noFill/>
-          <a:ln/>
-        </p:spPr>
+          <a:solidFill>
+            <a:schemeClr val="bg1">
+              <a:lumMod val="95000"/>
+            </a:schemeClr>
+          </a:solidFill>
+          <a:ln>
+            <a:noFill/>
+          </a:ln>
+        </p:spPr>
+        <p:style>
+          <a:lnRef idx="2">
+            <a:schemeClr val="accent1">
+              <a:shade val="15000"/>
+            </a:schemeClr>
+          </a:lnRef>
+          <a:fillRef idx="1">
+            <a:schemeClr val="accent1"/>
+          </a:fillRef>
+          <a:effectRef idx="0">
+            <a:schemeClr val="accent1"/>
+          </a:effectRef>
+          <a:fontRef idx="minor">
+            <a:schemeClr val="lt1"/>
+          </a:fontRef>
+        </p:style>
         <p:txBody>
-          <a:bodyPr wrap="square" lIns="0" tIns="0" rIns="0" bIns="0" rtlCol="0" anchor="ctr"/>
+          <a:bodyPr rtlCol="0" anchor="ctr"/>
           <a:lstStyle/>
           <a:p>
-            <a:pPr marL="0" indent="0" algn="ctr">
-              <a:buNone/>
-            </a:pPr>
-            <a:r>
-              <a:rPr lang="es-CL" sz="1400" b="1" kern="0" spc="150" noProof="0" dirty="0">
-                <a:solidFill>
-                  <a:srgbClr val="1F2A44"/>
-                </a:solidFill>
-                <a:latin typeface="Arial" pitchFamily="34" charset="0"/>
-                <a:ea typeface="Arial" pitchFamily="34" charset="-122"/>
-                <a:cs typeface="Arial" pitchFamily="34" charset="-120"/>
-              </a:rPr>
-              <a:t>ROBOT MOVIL</a:t>
-            </a:r>
-            <a:endParaRPr lang="es-CL" sz="1400" noProof="0" dirty="0"/>
-          </a:p>
-        </p:txBody>
-      </p:sp>
-      <p:sp>
-        <p:nvSpPr>
-          <p:cNvPr id="3" name="Text 1"/>
-          <p:cNvSpPr/>
-          <p:nvPr/>
-        </p:nvSpPr>
-        <p:spPr>
-          <a:xfrm>
-            <a:off x="5943600" y="32419"/>
-            <a:ext cx="3063240" cy="310896"/>
-          </a:xfrm>
-          <a:prstGeom prst="rect">
-            <a:avLst/>
-          </a:prstGeom>
-          <a:noFill/>
-          <a:ln/>
-        </p:spPr>
-        <p:txBody>
-          <a:bodyPr wrap="square" lIns="0" tIns="0" rIns="0" bIns="0" rtlCol="0" anchor="ctr"/>
-          <a:lstStyle/>
-          <a:p>
-            <a:pPr marL="0" indent="0" algn="ctr">
-              <a:buNone/>
-            </a:pPr>
-            <a:r>
-              <a:rPr lang="es-CL" sz="1400" b="1" kern="0" spc="150" noProof="0" dirty="0">
-                <a:solidFill>
-                  <a:srgbClr val="1F2A44"/>
-                </a:solidFill>
-                <a:latin typeface="Arial" pitchFamily="34" charset="0"/>
-                <a:ea typeface="Arial" pitchFamily="34" charset="-122"/>
-                <a:cs typeface="Arial" pitchFamily="34" charset="-120"/>
-              </a:rPr>
-              <a:t>ESTACIÓN DE TRABAJO</a:t>
-            </a:r>
-            <a:endParaRPr lang="es-CL" sz="1400" noProof="0" dirty="0"/>
+            <a:pPr algn="ctr"/>
+            <a:endParaRPr lang="en-US"/>
           </a:p>
         </p:txBody>
       </p:sp>
@@ -744,8 +720,8 @@
         </p:nvSpPr>
         <p:spPr>
           <a:xfrm>
-            <a:off x="137161" y="361602"/>
-            <a:ext cx="4105656" cy="4288743"/>
+            <a:off x="70103" y="378125"/>
+            <a:ext cx="3852637" cy="4288743"/>
           </a:xfrm>
           <a:prstGeom prst="roundRect">
             <a:avLst>
@@ -778,8 +754,8 @@
         </p:nvSpPr>
         <p:spPr>
           <a:xfrm>
-            <a:off x="5559553" y="361603"/>
-            <a:ext cx="3447287" cy="4288742"/>
+            <a:off x="5235945" y="361603"/>
+            <a:ext cx="3852637" cy="4288742"/>
           </a:xfrm>
           <a:prstGeom prst="roundRect">
             <a:avLst>
@@ -812,8 +788,8 @@
         </p:nvSpPr>
         <p:spPr>
           <a:xfrm>
-            <a:off x="251460" y="471332"/>
-            <a:ext cx="3863340" cy="1188856"/>
+            <a:off x="163918" y="471331"/>
+            <a:ext cx="3655226" cy="1277335"/>
           </a:xfrm>
           <a:prstGeom prst="roundRect">
             <a:avLst>
@@ -841,7 +817,7 @@
         </p:nvSpPr>
         <p:spPr>
           <a:xfrm>
-            <a:off x="1366520" y="493155"/>
+            <a:off x="1113536" y="493155"/>
             <a:ext cx="1783080" cy="219456"/>
           </a:xfrm>
           <a:prstGeom prst="rect">
@@ -880,7 +856,7 @@
         </p:nvSpPr>
         <p:spPr>
           <a:xfrm>
-            <a:off x="246214" y="1966525"/>
+            <a:off x="170014" y="2070434"/>
             <a:ext cx="1988820" cy="2461261"/>
           </a:xfrm>
           <a:prstGeom prst="roundRect">
@@ -909,8 +885,8 @@
         </p:nvSpPr>
         <p:spPr>
           <a:xfrm>
-            <a:off x="355942" y="2049240"/>
-            <a:ext cx="1752600" cy="219456"/>
+            <a:off x="243166" y="2153148"/>
+            <a:ext cx="208026" cy="2285985"/>
           </a:xfrm>
           <a:prstGeom prst="rect">
             <a:avLst/>
@@ -919,7 +895,7 @@
           <a:ln/>
         </p:spPr>
         <p:txBody>
-          <a:bodyPr wrap="square" lIns="0" tIns="0" rIns="0" bIns="0" rtlCol="0" anchor="ctr"/>
+          <a:bodyPr vert="vert270" wrap="square" lIns="0" tIns="0" rIns="0" bIns="0" rtlCol="0" anchor="ctr"/>
           <a:lstStyle/>
           <a:p>
             <a:pPr marL="0" indent="0" algn="ctr">
@@ -948,7 +924,7 @@
         </p:nvSpPr>
         <p:spPr>
           <a:xfrm>
-            <a:off x="2478532" y="727604"/>
+            <a:off x="2207260" y="727604"/>
             <a:ext cx="1463040" cy="859053"/>
           </a:xfrm>
           <a:prstGeom prst="roundRect">
@@ -982,7 +958,7 @@
         </p:nvSpPr>
         <p:spPr>
           <a:xfrm>
-            <a:off x="2524252" y="1138602"/>
+            <a:off x="2252980" y="1138602"/>
             <a:ext cx="1371600" cy="288036"/>
           </a:xfrm>
           <a:prstGeom prst="rect">
@@ -1055,7 +1031,7 @@
         </p:nvSpPr>
         <p:spPr>
           <a:xfrm>
-            <a:off x="510032" y="704366"/>
+            <a:off x="318008" y="704366"/>
             <a:ext cx="1463040" cy="853994"/>
           </a:xfrm>
           <a:prstGeom prst="roundRect">
@@ -1089,7 +1065,7 @@
         </p:nvSpPr>
         <p:spPr>
           <a:xfrm>
-            <a:off x="510032" y="1088414"/>
+            <a:off x="318008" y="1088414"/>
             <a:ext cx="1463040" cy="566928"/>
           </a:xfrm>
           <a:prstGeom prst="rect">
@@ -1163,211 +1139,113 @@
           </a:p>
         </p:txBody>
       </p:sp>
-      <p:grpSp>
-        <p:nvGrpSpPr>
-          <p:cNvPr id="87" name="Group 86">
-            <a:extLst>
-              <a:ext uri="{FF2B5EF4-FFF2-40B4-BE49-F238E27FC236}">
-                <a16:creationId xmlns:a16="http://schemas.microsoft.com/office/drawing/2014/main" id="{AED56D1A-5BD6-3E35-5706-2C6B19D2164F}"/>
-              </a:ext>
-            </a:extLst>
-          </p:cNvPr>
-          <p:cNvGrpSpPr/>
-          <p:nvPr/>
-        </p:nvGrpSpPr>
-        <p:grpSpPr>
-          <a:xfrm>
-            <a:off x="2318004" y="1966374"/>
-            <a:ext cx="1783080" cy="1463040"/>
-            <a:chOff x="2331720" y="1952490"/>
-            <a:chExt cx="1783080" cy="1463040"/>
-          </a:xfrm>
-        </p:grpSpPr>
-        <p:sp>
-          <p:nvSpPr>
-            <p:cNvPr id="8" name="Shape 6"/>
-            <p:cNvSpPr/>
-            <p:nvPr/>
-          </p:nvSpPr>
-          <p:spPr>
-            <a:xfrm>
-              <a:off x="2331720" y="1952490"/>
-              <a:ext cx="1783080" cy="1463040"/>
-            </a:xfrm>
-            <a:prstGeom prst="roundRect">
-              <a:avLst>
-                <a:gd name="adj" fmla="val 4375"/>
-              </a:avLst>
-            </a:prstGeom>
-            <a:solidFill>
-              <a:srgbClr val="E7EEF8"/>
-            </a:solidFill>
-            <a:ln/>
-          </p:spPr>
-          <p:txBody>
-            <a:bodyPr/>
-            <a:lstStyle/>
-            <a:p>
-              <a:endParaRPr lang="es-CL" noProof="0" dirty="0"/>
-            </a:p>
-          </p:txBody>
-        </p:sp>
-        <p:sp>
-          <p:nvSpPr>
-            <p:cNvPr id="9" name="Text 7"/>
-            <p:cNvSpPr/>
-            <p:nvPr/>
-          </p:nvSpPr>
-          <p:spPr>
-            <a:xfrm>
-              <a:off x="2331720" y="1989066"/>
-              <a:ext cx="1783080" cy="219456"/>
-            </a:xfrm>
-            <a:prstGeom prst="rect">
-              <a:avLst/>
-            </a:prstGeom>
-            <a:noFill/>
-            <a:ln/>
-          </p:spPr>
-          <p:txBody>
-            <a:bodyPr wrap="square" lIns="0" tIns="0" rIns="0" bIns="0" rtlCol="0" anchor="ctr"/>
-            <a:lstStyle/>
-            <a:p>
-              <a:pPr marL="0" indent="0" algn="ctr">
-                <a:buNone/>
-              </a:pPr>
-              <a:r>
-                <a:rPr lang="es-CL" sz="850" b="1" kern="0" spc="100" noProof="0" dirty="0">
-                  <a:solidFill>
-                    <a:srgbClr val="1E4176"/>
-                  </a:solidFill>
-                  <a:latin typeface="Arial" pitchFamily="34" charset="0"/>
-                  <a:ea typeface="Arial" pitchFamily="34" charset="-122"/>
-                  <a:cs typeface="Arial" pitchFamily="34" charset="-120"/>
-                </a:rPr>
-                <a:t>CÓMPUTO EMBARCADO</a:t>
-              </a:r>
-              <a:endParaRPr lang="es-CL" sz="850" noProof="0" dirty="0"/>
-            </a:p>
-          </p:txBody>
-        </p:sp>
-        <p:sp>
-          <p:nvSpPr>
-            <p:cNvPr id="22" name="Shape 20"/>
-            <p:cNvSpPr/>
-            <p:nvPr/>
-          </p:nvSpPr>
-          <p:spPr>
-            <a:xfrm>
-              <a:off x="2555240" y="2272529"/>
-              <a:ext cx="1325880" cy="959873"/>
-            </a:xfrm>
-            <a:prstGeom prst="roundRect">
-              <a:avLst>
-                <a:gd name="adj" fmla="val 6957"/>
-              </a:avLst>
-            </a:prstGeom>
+      <p:sp>
+        <p:nvSpPr>
+          <p:cNvPr id="22" name="Shape 20"/>
+          <p:cNvSpPr/>
+          <p:nvPr/>
+        </p:nvSpPr>
+        <p:spPr>
+          <a:xfrm>
+            <a:off x="2355596" y="2390322"/>
+            <a:ext cx="1325880" cy="959873"/>
+          </a:xfrm>
+          <a:prstGeom prst="roundRect">
+            <a:avLst>
+              <a:gd name="adj" fmla="val 6957"/>
+            </a:avLst>
+          </a:prstGeom>
+          <a:solidFill>
+            <a:srgbClr val="2B5AA0"/>
+          </a:solidFill>
+          <a:ln w="9525">
             <a:solidFill>
               <a:srgbClr val="2B5AA0"/>
             </a:solidFill>
-            <a:ln w="9525">
-              <a:solidFill>
-                <a:srgbClr val="2B5AA0"/>
-              </a:solidFill>
-              <a:prstDash val="solid"/>
-            </a:ln>
-          </p:spPr>
-          <p:txBody>
-            <a:bodyPr/>
-            <a:lstStyle/>
-            <a:p>
-              <a:endParaRPr lang="es-CL" noProof="0" dirty="0"/>
-            </a:p>
-          </p:txBody>
-        </p:sp>
-        <p:sp>
-          <p:nvSpPr>
-            <p:cNvPr id="29" name="Text 27"/>
-            <p:cNvSpPr/>
-            <p:nvPr/>
-          </p:nvSpPr>
-          <p:spPr>
-            <a:xfrm>
-              <a:off x="2600960" y="2656578"/>
-              <a:ext cx="1253490" cy="507246"/>
-            </a:xfrm>
-            <a:prstGeom prst="rect">
-              <a:avLst/>
-            </a:prstGeom>
-            <a:noFill/>
-            <a:ln/>
-          </p:spPr>
-          <p:txBody>
-            <a:bodyPr wrap="square" lIns="0" tIns="0" rIns="0" bIns="0" rtlCol="0" anchor="t"/>
-            <a:lstStyle/>
-            <a:p>
-              <a:pPr marL="0" indent="0" algn="ctr">
-                <a:lnSpc>
-                  <a:spcPct val="98000"/>
-                </a:lnSpc>
-                <a:buNone/>
-              </a:pPr>
-              <a:r>
-                <a:rPr lang="es-CL" sz="1050" b="1" noProof="0" dirty="0">
-                  <a:solidFill>
-                    <a:srgbClr val="FFFFFF"/>
-                  </a:solidFill>
-                  <a:latin typeface="Arial" pitchFamily="34" charset="0"/>
-                  <a:ea typeface="Arial" pitchFamily="34" charset="-122"/>
-                  <a:cs typeface="Arial" pitchFamily="34" charset="-120"/>
-                </a:rPr>
-                <a:t>Raspberry Pi 4</a:t>
-              </a:r>
-              <a:endParaRPr lang="es-CL" sz="1050" noProof="0" dirty="0"/>
-            </a:p>
-            <a:p>
-              <a:pPr marL="0" indent="0" algn="ctr">
-                <a:lnSpc>
-                  <a:spcPct val="98000"/>
-                </a:lnSpc>
-                <a:buNone/>
-              </a:pPr>
-              <a:r>
-                <a:rPr lang="es-CL" sz="790" noProof="0" dirty="0">
-                  <a:solidFill>
-                    <a:srgbClr val="F1F5FA"/>
-                  </a:solidFill>
-                  <a:latin typeface="Arial" pitchFamily="34" charset="0"/>
-                  <a:ea typeface="Arial" pitchFamily="34" charset="-122"/>
-                  <a:cs typeface="Arial" pitchFamily="34" charset="-120"/>
-                </a:rPr>
-                <a:t>Computador a bordo</a:t>
-              </a:r>
-              <a:endParaRPr lang="es-CL" sz="1050" noProof="0" dirty="0"/>
-            </a:p>
-            <a:p>
-              <a:pPr marL="0" indent="0" algn="ctr">
-                <a:lnSpc>
-                  <a:spcPct val="98000"/>
-                </a:lnSpc>
-                <a:buNone/>
-              </a:pPr>
-              <a:r>
-                <a:rPr lang="es-CL" sz="790" noProof="0" dirty="0">
-                  <a:solidFill>
-                    <a:srgbClr val="F1F5FA"/>
-                  </a:solidFill>
-                  <a:latin typeface="Arial" pitchFamily="34" charset="0"/>
-                  <a:ea typeface="Arial" pitchFamily="34" charset="-122"/>
-                  <a:cs typeface="Arial" pitchFamily="34" charset="-120"/>
-                </a:rPr>
-                <a:t>Comunicación y gestión</a:t>
-              </a:r>
-              <a:endParaRPr lang="es-CL" sz="1050" noProof="0" dirty="0"/>
-            </a:p>
-          </p:txBody>
-        </p:sp>
-      </p:grpSp>
+            <a:prstDash val="solid"/>
+          </a:ln>
+        </p:spPr>
+        <p:txBody>
+          <a:bodyPr/>
+          <a:lstStyle/>
+          <a:p>
+            <a:endParaRPr lang="es-CL" noProof="0" dirty="0"/>
+          </a:p>
+        </p:txBody>
+      </p:sp>
+      <p:sp>
+        <p:nvSpPr>
+          <p:cNvPr id="29" name="Text 27"/>
+          <p:cNvSpPr/>
+          <p:nvPr/>
+        </p:nvSpPr>
+        <p:spPr>
+          <a:xfrm>
+            <a:off x="2401316" y="2774371"/>
+            <a:ext cx="1253490" cy="507246"/>
+          </a:xfrm>
+          <a:prstGeom prst="rect">
+            <a:avLst/>
+          </a:prstGeom>
+          <a:noFill/>
+          <a:ln/>
+        </p:spPr>
+        <p:txBody>
+          <a:bodyPr wrap="square" lIns="0" tIns="0" rIns="0" bIns="0" rtlCol="0" anchor="t"/>
+          <a:lstStyle/>
+          <a:p>
+            <a:pPr marL="0" indent="0" algn="ctr">
+              <a:lnSpc>
+                <a:spcPct val="98000"/>
+              </a:lnSpc>
+              <a:buNone/>
+            </a:pPr>
+            <a:r>
+              <a:rPr lang="es-CL" sz="1050" b="1" noProof="0" dirty="0">
+                <a:solidFill>
+                  <a:srgbClr val="FFFFFF"/>
+                </a:solidFill>
+                <a:latin typeface="Arial" pitchFamily="34" charset="0"/>
+                <a:ea typeface="Arial" pitchFamily="34" charset="-122"/>
+                <a:cs typeface="Arial" pitchFamily="34" charset="-120"/>
+              </a:rPr>
+              <a:t>Raspberry Pi 4</a:t>
+            </a:r>
+            <a:endParaRPr lang="es-CL" sz="1050" noProof="0" dirty="0"/>
+          </a:p>
+          <a:p>
+            <a:pPr marL="0" indent="0" algn="ctr">
+              <a:lnSpc>
+                <a:spcPct val="98000"/>
+              </a:lnSpc>
+              <a:buNone/>
+            </a:pPr>
+            <a:r>
+              <a:rPr lang="es-ES" sz="790" noProof="0" dirty="0">
+                <a:solidFill>
+                  <a:srgbClr val="F1F5FA"/>
+                </a:solidFill>
+                <a:latin typeface="Arial" pitchFamily="34" charset="0"/>
+                <a:ea typeface="Arial" pitchFamily="34" charset="-122"/>
+                <a:cs typeface="Arial" pitchFamily="34" charset="-120"/>
+              </a:rPr>
+              <a:t>Integración ROS 2 y estimación de </a:t>
+            </a:r>
+            <a:r>
+              <a:rPr lang="es-ES" sz="790" noProof="0" dirty="0" err="1">
+                <a:solidFill>
+                  <a:srgbClr val="F1F5FA"/>
+                </a:solidFill>
+                <a:latin typeface="Arial" pitchFamily="34" charset="0"/>
+                <a:ea typeface="Arial" pitchFamily="34" charset="-122"/>
+                <a:cs typeface="Arial" pitchFamily="34" charset="-120"/>
+              </a:rPr>
+              <a:t>odometría</a:t>
+            </a:r>
+            <a:endParaRPr lang="es-CL" sz="1050" noProof="0" dirty="0"/>
+          </a:p>
+        </p:txBody>
+      </p:sp>
       <p:sp>
         <p:nvSpPr>
           <p:cNvPr id="30" name="Shape 28"/>
@@ -1376,7 +1254,7 @@
         </p:nvSpPr>
         <p:spPr>
           <a:xfrm>
-            <a:off x="609688" y="2364570"/>
+            <a:off x="533488" y="2468479"/>
             <a:ext cx="1188720" cy="808963"/>
           </a:xfrm>
           <a:prstGeom prst="roundRect">
@@ -1410,7 +1288,7 @@
         </p:nvSpPr>
         <p:spPr>
           <a:xfrm>
-            <a:off x="655408" y="2705112"/>
+            <a:off x="579208" y="2809021"/>
             <a:ext cx="1097280" cy="566928"/>
           </a:xfrm>
           <a:prstGeom prst="rect">
@@ -1450,7 +1328,7 @@
               <a:buNone/>
             </a:pPr>
             <a:r>
-              <a:rPr lang="es-CL" sz="790" noProof="0" dirty="0">
+              <a:rPr lang="es-ES" sz="790" noProof="0" dirty="0">
                 <a:solidFill>
                   <a:srgbClr val="F1F5FA"/>
                 </a:solidFill>
@@ -1458,19 +1336,10 @@
                 <a:ea typeface="Arial" pitchFamily="34" charset="-122"/>
                 <a:cs typeface="Arial" pitchFamily="34" charset="-120"/>
               </a:rPr>
-              <a:t>Control de velocidad</a:t>
+              <a:t>Control PID y lectura de </a:t>
             </a:r>
-            <a:endParaRPr lang="es-CL" sz="1050" noProof="0" dirty="0"/>
-          </a:p>
-          <a:p>
-            <a:pPr marL="0" indent="0" algn="ctr">
-              <a:lnSpc>
-                <a:spcPct val="98000"/>
-              </a:lnSpc>
-              <a:buNone/>
-            </a:pPr>
             <a:r>
-              <a:rPr lang="es-CL" sz="790" noProof="0" dirty="0">
+              <a:rPr lang="es-ES" sz="790" noProof="0" dirty="0" err="1">
                 <a:solidFill>
                   <a:srgbClr val="F1F5FA"/>
                 </a:solidFill>
@@ -1478,18 +1347,7 @@
                 <a:ea typeface="Arial" pitchFamily="34" charset="-122"/>
                 <a:cs typeface="Arial" pitchFamily="34" charset="-120"/>
               </a:rPr>
-              <a:t>y </a:t>
-            </a:r>
-            <a:r>
-              <a:rPr lang="es-CL" sz="790" noProof="0" dirty="0" err="1">
-                <a:solidFill>
-                  <a:srgbClr val="F1F5FA"/>
-                </a:solidFill>
-                <a:latin typeface="Arial" pitchFamily="34" charset="0"/>
-                <a:ea typeface="Arial" pitchFamily="34" charset="-122"/>
-                <a:cs typeface="Arial" pitchFamily="34" charset="-120"/>
-              </a:rPr>
-              <a:t>odometría</a:t>
+              <a:t>encoders</a:t>
             </a:r>
             <a:endParaRPr lang="es-CL" sz="1050" noProof="0" dirty="0"/>
           </a:p>
@@ -1503,7 +1361,7 @@
         </p:nvSpPr>
         <p:spPr>
           <a:xfrm>
-            <a:off x="614260" y="3433266"/>
+            <a:off x="538060" y="3537175"/>
             <a:ext cx="1188720" cy="859446"/>
           </a:xfrm>
           <a:prstGeom prst="roundRect">
@@ -1537,7 +1395,7 @@
         </p:nvSpPr>
         <p:spPr>
           <a:xfrm>
-            <a:off x="660968" y="3817314"/>
+            <a:off x="584768" y="3921223"/>
             <a:ext cx="1120993" cy="406909"/>
           </a:xfrm>
           <a:prstGeom prst="rect">
@@ -1619,8 +1477,8 @@
         </p:nvSpPr>
         <p:spPr>
           <a:xfrm>
-            <a:off x="5750236" y="712611"/>
-            <a:ext cx="1280160" cy="935077"/>
+            <a:off x="5374725" y="720265"/>
+            <a:ext cx="1860132" cy="935077"/>
           </a:xfrm>
           <a:prstGeom prst="roundRect">
             <a:avLst>
@@ -1647,132 +1505,14 @@
       </p:sp>
       <p:sp>
         <p:nvSpPr>
-          <p:cNvPr id="46" name="Shape 44"/>
-          <p:cNvSpPr/>
-          <p:nvPr/>
-        </p:nvSpPr>
-        <p:spPr>
-          <a:xfrm>
-            <a:off x="6262300" y="902206"/>
-            <a:ext cx="256032" cy="201168"/>
-          </a:xfrm>
-          <a:prstGeom prst="roundRect">
-            <a:avLst>
-              <a:gd name="adj" fmla="val 13636"/>
-            </a:avLst>
-          </a:prstGeom>
-          <a:ln w="15875">
-            <a:solidFill>
-              <a:srgbClr val="FFFFFF"/>
-            </a:solidFill>
-            <a:prstDash val="solid"/>
-          </a:ln>
-        </p:spPr>
-        <p:txBody>
-          <a:bodyPr/>
-          <a:lstStyle/>
-          <a:p>
-            <a:endParaRPr lang="es-CL" noProof="0" dirty="0"/>
-          </a:p>
-        </p:txBody>
-      </p:sp>
-      <p:sp>
-        <p:nvSpPr>
-          <p:cNvPr id="47" name="Shape 45"/>
-          <p:cNvSpPr/>
-          <p:nvPr/>
-        </p:nvSpPr>
-        <p:spPr>
-          <a:xfrm>
-            <a:off x="6344596" y="902206"/>
-            <a:ext cx="91" cy="201168"/>
-          </a:xfrm>
-          <a:prstGeom prst="line">
-            <a:avLst/>
-          </a:prstGeom>
-          <a:noFill/>
-          <a:ln w="15875">
-            <a:solidFill>
-              <a:srgbClr val="FFFFFF"/>
-            </a:solidFill>
-            <a:prstDash val="solid"/>
-          </a:ln>
-        </p:spPr>
-        <p:txBody>
-          <a:bodyPr/>
-          <a:lstStyle/>
-          <a:p>
-            <a:endParaRPr lang="es-CL" noProof="0" dirty="0"/>
-          </a:p>
-        </p:txBody>
-      </p:sp>
-      <p:sp>
-        <p:nvSpPr>
-          <p:cNvPr id="48" name="Shape 46"/>
-          <p:cNvSpPr/>
-          <p:nvPr/>
-        </p:nvSpPr>
-        <p:spPr>
-          <a:xfrm>
-            <a:off x="6262300" y="993646"/>
-            <a:ext cx="256032" cy="91"/>
-          </a:xfrm>
-          <a:prstGeom prst="line">
-            <a:avLst/>
-          </a:prstGeom>
-          <a:noFill/>
-          <a:ln w="15875">
-            <a:solidFill>
-              <a:srgbClr val="FFFFFF"/>
-            </a:solidFill>
-            <a:prstDash val="solid"/>
-          </a:ln>
-        </p:spPr>
-        <p:txBody>
-          <a:bodyPr/>
-          <a:lstStyle/>
-          <a:p>
-            <a:endParaRPr lang="es-CL" noProof="0" dirty="0"/>
-          </a:p>
-        </p:txBody>
-      </p:sp>
-      <p:sp>
-        <p:nvSpPr>
-          <p:cNvPr id="49" name="Shape 47"/>
-          <p:cNvSpPr/>
-          <p:nvPr/>
-        </p:nvSpPr>
-        <p:spPr>
-          <a:xfrm>
-            <a:off x="6417748" y="1011934"/>
-            <a:ext cx="54864" cy="54864"/>
-          </a:xfrm>
-          <a:prstGeom prst="ellipse">
-            <a:avLst/>
-          </a:prstGeom>
-          <a:solidFill>
-            <a:srgbClr val="FFFFFF"/>
-          </a:solidFill>
-          <a:ln/>
-        </p:spPr>
-        <p:txBody>
-          <a:bodyPr/>
-          <a:lstStyle/>
-          <a:p>
-            <a:endParaRPr lang="es-CL" noProof="0" dirty="0"/>
-          </a:p>
-        </p:txBody>
-      </p:sp>
-      <p:sp>
-        <p:nvSpPr>
           <p:cNvPr id="50" name="Text 48"/>
           <p:cNvSpPr/>
           <p:nvPr/>
         </p:nvSpPr>
         <p:spPr>
           <a:xfrm>
-            <a:off x="5795956" y="1176526"/>
-            <a:ext cx="1188720" cy="429562"/>
+            <a:off x="6121483" y="792478"/>
+            <a:ext cx="930994" cy="813610"/>
           </a:xfrm>
           <a:prstGeom prst="rect">
             <a:avLst/>
@@ -1781,7 +1521,7 @@
           <a:ln/>
         </p:spPr>
         <p:txBody>
-          <a:bodyPr wrap="square" lIns="0" tIns="0" rIns="0" bIns="0" rtlCol="0" anchor="t"/>
+          <a:bodyPr wrap="square" lIns="0" tIns="0" rIns="0" bIns="0" rtlCol="0" anchor="ctr"/>
           <a:lstStyle/>
           <a:p>
             <a:pPr marL="0" indent="0" algn="ctr">
@@ -1864,8 +1604,8 @@
         </p:nvSpPr>
         <p:spPr>
           <a:xfrm>
-            <a:off x="5738599" y="2337904"/>
-            <a:ext cx="1280160" cy="845819"/>
+            <a:off x="5401239" y="2374621"/>
+            <a:ext cx="1280160" cy="987551"/>
           </a:xfrm>
           <a:prstGeom prst="roundRect">
             <a:avLst>
@@ -1898,7 +1638,7 @@
         </p:nvSpPr>
         <p:spPr>
           <a:xfrm>
-            <a:off x="5784319" y="2721952"/>
+            <a:off x="5446959" y="2832788"/>
             <a:ext cx="1188720" cy="429562"/>
           </a:xfrm>
           <a:prstGeom prst="rect">
@@ -1980,8 +1720,8 @@
         </p:nvSpPr>
         <p:spPr>
           <a:xfrm>
-            <a:off x="7507315" y="712611"/>
-            <a:ext cx="1280160" cy="935077"/>
+            <a:off x="7604294" y="719538"/>
+            <a:ext cx="1293491" cy="935077"/>
           </a:xfrm>
           <a:prstGeom prst="roundRect">
             <a:avLst>
@@ -2014,7 +1754,7 @@
         </p:nvSpPr>
         <p:spPr>
           <a:xfrm>
-            <a:off x="7553035" y="1176526"/>
+            <a:off x="7656679" y="1195491"/>
             <a:ext cx="1188720" cy="413884"/>
           </a:xfrm>
           <a:prstGeom prst="rect">
@@ -2062,9 +1802,85 @@
                 <a:ea typeface="Arial" pitchFamily="34" charset="-122"/>
                 <a:cs typeface="Arial" pitchFamily="34" charset="-120"/>
               </a:rPr>
-              <a:t>Visualización</a:t>
+              <a:t>Visualización y supervisión</a:t>
             </a:r>
             <a:endParaRPr lang="es-CL" sz="1050" noProof="0" dirty="0"/>
+          </a:p>
+        </p:txBody>
+      </p:sp>
+      <p:sp>
+        <p:nvSpPr>
+          <p:cNvPr id="61" name="Shape 59"/>
+          <p:cNvSpPr/>
+          <p:nvPr/>
+        </p:nvSpPr>
+        <p:spPr>
+          <a:xfrm>
+            <a:off x="7066092" y="2374621"/>
+            <a:ext cx="1831694" cy="987552"/>
+          </a:xfrm>
+          <a:prstGeom prst="roundRect">
+            <a:avLst>
+              <a:gd name="adj" fmla="val 6400"/>
+            </a:avLst>
+          </a:prstGeom>
+          <a:solidFill>
+            <a:srgbClr val="654A97"/>
+          </a:solidFill>
+          <a:ln w="9525">
+            <a:solidFill>
+              <a:srgbClr val="654A97"/>
+            </a:solidFill>
+            <a:prstDash val="solid"/>
+          </a:ln>
+        </p:spPr>
+        <p:txBody>
+          <a:bodyPr/>
+          <a:lstStyle/>
+          <a:p>
+            <a:endParaRPr lang="es-CL" noProof="0" dirty="0"/>
+          </a:p>
+        </p:txBody>
+      </p:sp>
+      <p:sp>
+        <p:nvSpPr>
+          <p:cNvPr id="65" name="Text 63"/>
+          <p:cNvSpPr/>
+          <p:nvPr/>
+        </p:nvSpPr>
+        <p:spPr>
+          <a:xfrm>
+            <a:off x="7734803" y="2431900"/>
+            <a:ext cx="1036227" cy="884554"/>
+          </a:xfrm>
+          <a:prstGeom prst="rect">
+            <a:avLst/>
+          </a:prstGeom>
+          <a:noFill/>
+          <a:ln/>
+        </p:spPr>
+        <p:txBody>
+          <a:bodyPr wrap="square" lIns="0" tIns="0" rIns="0" bIns="0" rtlCol="0" anchor="ctr"/>
+          <a:lstStyle/>
+          <a:p>
+            <a:pPr marL="0" indent="0" algn="ctr">
+              <a:lnSpc>
+                <a:spcPct val="98000"/>
+              </a:lnSpc>
+              <a:buNone/>
+            </a:pPr>
+            <a:r>
+              <a:rPr lang="es-CL" sz="950" b="1" noProof="0" dirty="0">
+                <a:solidFill>
+                  <a:srgbClr val="FFFFFF"/>
+                </a:solidFill>
+                <a:latin typeface="Arial" pitchFamily="34" charset="0"/>
+                <a:ea typeface="Arial" pitchFamily="34" charset="-122"/>
+                <a:cs typeface="Arial" pitchFamily="34" charset="-120"/>
+              </a:rPr>
+              <a:t>Exploración por fronteras</a:t>
+            </a:r>
+            <a:endParaRPr lang="es-CL" sz="950" noProof="0" dirty="0"/>
           </a:p>
           <a:p>
             <a:pPr marL="0" indent="0" algn="ctr">
@@ -2082,272 +1898,29 @@
                 <a:ea typeface="Arial" pitchFamily="34" charset="-122"/>
                 <a:cs typeface="Arial" pitchFamily="34" charset="-120"/>
               </a:rPr>
-              <a:t>y supervisión</a:t>
+              <a:t>Generación autónoma</a:t>
             </a:r>
-            <a:endParaRPr lang="es-CL" sz="1050" noProof="0" dirty="0"/>
-          </a:p>
-        </p:txBody>
-      </p:sp>
-      <p:grpSp>
-        <p:nvGrpSpPr>
-          <p:cNvPr id="107" name="Group 106">
-            <a:extLst>
-              <a:ext uri="{FF2B5EF4-FFF2-40B4-BE49-F238E27FC236}">
-                <a16:creationId xmlns:a16="http://schemas.microsoft.com/office/drawing/2014/main" id="{00BA8D9D-74A8-ECE3-E17C-59943DCC7B80}"/>
-              </a:ext>
-            </a:extLst>
-          </p:cNvPr>
-          <p:cNvGrpSpPr/>
-          <p:nvPr/>
-        </p:nvGrpSpPr>
-        <p:grpSpPr>
-          <a:xfrm>
-            <a:off x="7571232" y="2263785"/>
-            <a:ext cx="1280160" cy="987552"/>
-            <a:chOff x="7589520" y="2693323"/>
-            <a:chExt cx="1280160" cy="987552"/>
-          </a:xfrm>
-        </p:grpSpPr>
-        <p:sp>
-          <p:nvSpPr>
-            <p:cNvPr id="61" name="Shape 59"/>
-            <p:cNvSpPr/>
-            <p:nvPr/>
-          </p:nvSpPr>
-          <p:spPr>
-            <a:xfrm>
-              <a:off x="7589520" y="2693323"/>
-              <a:ext cx="1280160" cy="987552"/>
-            </a:xfrm>
-            <a:prstGeom prst="roundRect">
-              <a:avLst>
-                <a:gd name="adj" fmla="val 6400"/>
-              </a:avLst>
-            </a:prstGeom>
-            <a:solidFill>
-              <a:srgbClr val="654A97"/>
-            </a:solidFill>
-            <a:ln w="9525">
-              <a:solidFill>
-                <a:srgbClr val="654A97"/>
-              </a:solidFill>
-              <a:prstDash val="solid"/>
-            </a:ln>
-          </p:spPr>
-          <p:txBody>
-            <a:bodyPr/>
-            <a:lstStyle/>
-            <a:p>
-              <a:endParaRPr lang="es-CL" noProof="0" dirty="0"/>
-            </a:p>
-          </p:txBody>
-        </p:sp>
-        <p:sp>
-          <p:nvSpPr>
-            <p:cNvPr id="62" name="Shape 60"/>
-            <p:cNvSpPr/>
-            <p:nvPr/>
-          </p:nvSpPr>
-          <p:spPr>
-            <a:xfrm>
-              <a:off x="8147304" y="2793907"/>
-              <a:ext cx="91" cy="219456"/>
-            </a:xfrm>
-            <a:prstGeom prst="line">
-              <a:avLst/>
-            </a:prstGeom>
-            <a:noFill/>
-            <a:ln w="15875">
-              <a:solidFill>
-                <a:srgbClr val="FFFFFF"/>
-              </a:solidFill>
-              <a:prstDash val="solid"/>
-            </a:ln>
-          </p:spPr>
-          <p:txBody>
-            <a:bodyPr/>
-            <a:lstStyle/>
-            <a:p>
-              <a:endParaRPr lang="es-CL" noProof="0" dirty="0"/>
-            </a:p>
-          </p:txBody>
-        </p:sp>
-        <p:sp>
-          <p:nvSpPr>
-            <p:cNvPr id="63" name="Shape 61"/>
-            <p:cNvSpPr/>
-            <p:nvPr/>
-          </p:nvSpPr>
-          <p:spPr>
-            <a:xfrm rot="5400000">
-              <a:off x="8147304" y="2793907"/>
-              <a:ext cx="155448" cy="100584"/>
-            </a:xfrm>
-            <a:prstGeom prst="triangle">
-              <a:avLst/>
-            </a:prstGeom>
-            <a:solidFill>
-              <a:srgbClr val="FFFFFF"/>
-            </a:solidFill>
-            <a:ln/>
-          </p:spPr>
-          <p:txBody>
-            <a:bodyPr/>
-            <a:lstStyle/>
-            <a:p>
-              <a:endParaRPr lang="es-CL" noProof="0" dirty="0"/>
-            </a:p>
-          </p:txBody>
-        </p:sp>
-        <p:sp>
-          <p:nvSpPr>
-            <p:cNvPr id="64" name="Shape 62"/>
-            <p:cNvSpPr/>
-            <p:nvPr/>
-          </p:nvSpPr>
-          <p:spPr>
-            <a:xfrm>
-              <a:off x="8124444" y="2976787"/>
-              <a:ext cx="45720" cy="45720"/>
-            </a:xfrm>
-            <a:prstGeom prst="ellipse">
-              <a:avLst/>
-            </a:prstGeom>
-            <a:solidFill>
-              <a:srgbClr val="FFFFFF"/>
-            </a:solidFill>
-            <a:ln/>
-          </p:spPr>
-          <p:txBody>
-            <a:bodyPr/>
-            <a:lstStyle/>
-            <a:p>
-              <a:endParaRPr lang="es-CL" noProof="0" dirty="0"/>
-            </a:p>
-          </p:txBody>
-        </p:sp>
-        <p:sp>
-          <p:nvSpPr>
-            <p:cNvPr id="65" name="Text 63"/>
-            <p:cNvSpPr/>
-            <p:nvPr/>
-          </p:nvSpPr>
-          <p:spPr>
-            <a:xfrm>
-              <a:off x="7635240" y="3077371"/>
-              <a:ext cx="1188720" cy="557784"/>
-            </a:xfrm>
-            <a:prstGeom prst="rect">
-              <a:avLst/>
-            </a:prstGeom>
-            <a:noFill/>
-            <a:ln/>
-          </p:spPr>
-          <p:txBody>
-            <a:bodyPr wrap="square" lIns="0" tIns="0" rIns="0" bIns="0" rtlCol="0" anchor="t"/>
-            <a:lstStyle/>
-            <a:p>
-              <a:pPr marL="0" indent="0" algn="ctr">
-                <a:lnSpc>
-                  <a:spcPct val="98000"/>
-                </a:lnSpc>
-                <a:buNone/>
-              </a:pPr>
-              <a:r>
-                <a:rPr lang="es-CL" sz="950" b="1" noProof="0" dirty="0">
-                  <a:solidFill>
-                    <a:srgbClr val="FFFFFF"/>
-                  </a:solidFill>
-                  <a:latin typeface="Arial" pitchFamily="34" charset="0"/>
-                  <a:ea typeface="Arial" pitchFamily="34" charset="-122"/>
-                  <a:cs typeface="Arial" pitchFamily="34" charset="-120"/>
-                </a:rPr>
-                <a:t>Exploración por fronteras</a:t>
-              </a:r>
-              <a:endParaRPr lang="es-CL" sz="950" noProof="0" dirty="0"/>
-            </a:p>
-            <a:p>
-              <a:pPr marL="0" indent="0" algn="ctr">
-                <a:lnSpc>
-                  <a:spcPct val="98000"/>
-                </a:lnSpc>
-                <a:buNone/>
-              </a:pPr>
-              <a:r>
-                <a:rPr lang="es-CL" sz="790" noProof="0" dirty="0">
-                  <a:solidFill>
-                    <a:srgbClr val="F1F5FA"/>
-                  </a:solidFill>
-                  <a:latin typeface="Arial" pitchFamily="34" charset="0"/>
-                  <a:ea typeface="Arial" pitchFamily="34" charset="-122"/>
-                  <a:cs typeface="Arial" pitchFamily="34" charset="-120"/>
-                </a:rPr>
-                <a:t>Generación autónoma</a:t>
-              </a:r>
-              <a:endParaRPr lang="es-CL" sz="950" noProof="0" dirty="0"/>
-            </a:p>
-            <a:p>
-              <a:pPr marL="0" indent="0" algn="ctr">
-                <a:lnSpc>
-                  <a:spcPct val="98000"/>
-                </a:lnSpc>
-                <a:buNone/>
-              </a:pPr>
-              <a:r>
-                <a:rPr lang="es-CL" sz="790" noProof="0" dirty="0">
-                  <a:solidFill>
-                    <a:srgbClr val="F1F5FA"/>
-                  </a:solidFill>
-                  <a:latin typeface="Arial" pitchFamily="34" charset="0"/>
-                  <a:ea typeface="Arial" pitchFamily="34" charset="-122"/>
-                  <a:cs typeface="Arial" pitchFamily="34" charset="-120"/>
-                </a:rPr>
-                <a:t>de metas</a:t>
-              </a:r>
-              <a:endParaRPr lang="es-CL" sz="950" noProof="0" dirty="0"/>
-            </a:p>
-          </p:txBody>
-        </p:sp>
-      </p:grpSp>
-      <p:sp>
-        <p:nvSpPr>
-          <p:cNvPr id="71" name="Text 69"/>
-          <p:cNvSpPr/>
-          <p:nvPr/>
-        </p:nvSpPr>
-        <p:spPr>
-          <a:xfrm>
-            <a:off x="4348711" y="2506510"/>
-            <a:ext cx="1097280" cy="282645"/>
-          </a:xfrm>
-          <a:prstGeom prst="rect">
-            <a:avLst/>
-          </a:prstGeom>
-          <a:noFill/>
-          <a:ln/>
-        </p:spPr>
-        <p:txBody>
-          <a:bodyPr wrap="square" lIns="0" tIns="0" rIns="0" bIns="0" rtlCol="0" anchor="ctr"/>
-          <a:lstStyle/>
+            <a:endParaRPr lang="es-CL" sz="950" noProof="0" dirty="0"/>
+          </a:p>
           <a:p>
             <a:pPr marL="0" indent="0" algn="ctr">
               <a:lnSpc>
-                <a:spcPct val="95000"/>
+                <a:spcPct val="98000"/>
               </a:lnSpc>
               <a:buNone/>
             </a:pPr>
             <a:r>
-              <a:rPr lang="es-CL" sz="800" i="1" noProof="0" dirty="0">
+              <a:rPr lang="es-CL" sz="790" noProof="0" dirty="0">
                 <a:solidFill>
-                  <a:srgbClr val="39485C"/>
+                  <a:srgbClr val="F1F5FA"/>
                 </a:solidFill>
                 <a:latin typeface="Arial" pitchFamily="34" charset="0"/>
                 <a:ea typeface="Arial" pitchFamily="34" charset="-122"/>
                 <a:cs typeface="Arial" pitchFamily="34" charset="-120"/>
               </a:rPr>
-              <a:t>Intercambio de datos</a:t>
+              <a:t>de metas</a:t>
             </a:r>
-            <a:endParaRPr lang="es-CL" sz="800" noProof="0" dirty="0"/>
+            <a:endParaRPr lang="es-CL" sz="950" noProof="0" dirty="0"/>
           </a:p>
         </p:txBody>
       </p:sp>
@@ -2359,7 +1932,7 @@
         </p:nvSpPr>
         <p:spPr>
           <a:xfrm>
-            <a:off x="1847088" y="4803095"/>
+            <a:off x="1653590" y="4839671"/>
             <a:ext cx="155448" cy="155448"/>
           </a:xfrm>
           <a:prstGeom prst="roundRect">
@@ -2388,7 +1961,7 @@
         </p:nvSpPr>
         <p:spPr>
           <a:xfrm>
-            <a:off x="2057400" y="4748231"/>
+            <a:off x="1863902" y="4784807"/>
             <a:ext cx="566928" cy="274320"/>
           </a:xfrm>
           <a:prstGeom prst="rect">
@@ -2427,7 +2000,7 @@
         </p:nvSpPr>
         <p:spPr>
           <a:xfrm>
-            <a:off x="2825496" y="4803095"/>
+            <a:off x="2631998" y="4839671"/>
             <a:ext cx="155448" cy="155448"/>
           </a:xfrm>
           <a:prstGeom prst="roundRect">
@@ -2456,7 +2029,7 @@
         </p:nvSpPr>
         <p:spPr>
           <a:xfrm>
-            <a:off x="3035808" y="4748231"/>
+            <a:off x="2842310" y="4784807"/>
             <a:ext cx="1207008" cy="274320"/>
           </a:xfrm>
           <a:prstGeom prst="rect">
@@ -2495,7 +2068,7 @@
         </p:nvSpPr>
         <p:spPr>
           <a:xfrm>
-            <a:off x="4443984" y="4803095"/>
+            <a:off x="4250486" y="4839671"/>
             <a:ext cx="155448" cy="155448"/>
           </a:xfrm>
           <a:prstGeom prst="roundRect">
@@ -2524,8 +2097,8 @@
         </p:nvSpPr>
         <p:spPr>
           <a:xfrm>
-            <a:off x="4654296" y="4748231"/>
-            <a:ext cx="1078992" cy="274320"/>
+            <a:off x="4460797" y="4784807"/>
+            <a:ext cx="1731535" cy="274320"/>
           </a:xfrm>
           <a:prstGeom prst="rect">
             <a:avLst/>
@@ -2549,7 +2122,7 @@
                 <a:ea typeface="Arial" pitchFamily="34" charset="-122"/>
                 <a:cs typeface="Arial" pitchFamily="34" charset="-120"/>
               </a:rPr>
-              <a:t>Cómputo embarcado</a:t>
+              <a:t>Sistema computacional del robot</a:t>
             </a:r>
             <a:endParaRPr lang="es-CL" sz="900" noProof="0" dirty="0"/>
           </a:p>
@@ -2563,7 +2136,7 @@
         </p:nvSpPr>
         <p:spPr>
           <a:xfrm>
-            <a:off x="5934456" y="4803095"/>
+            <a:off x="6391198" y="4839671"/>
             <a:ext cx="155448" cy="155448"/>
           </a:xfrm>
           <a:prstGeom prst="roundRect">
@@ -2592,7 +2165,7 @@
         </p:nvSpPr>
         <p:spPr>
           <a:xfrm>
-            <a:off x="6144768" y="4748231"/>
+            <a:off x="6601510" y="4784807"/>
             <a:ext cx="1115568" cy="274320"/>
           </a:xfrm>
           <a:prstGeom prst="rect">
@@ -2640,94 +2213,10 @@
         </p:nvCxnSpPr>
         <p:spPr>
           <a:xfrm>
-            <a:off x="1204048" y="3173533"/>
+            <a:off x="1127848" y="3277442"/>
             <a:ext cx="4572" cy="259733"/>
           </a:xfrm>
           <a:prstGeom prst="straightConnector1">
-            <a:avLst/>
-          </a:prstGeom>
-          <a:ln>
-            <a:tailEnd type="triangle"/>
-          </a:ln>
-        </p:spPr>
-        <p:style>
-          <a:lnRef idx="1">
-            <a:schemeClr val="accent1"/>
-          </a:lnRef>
-          <a:fillRef idx="0">
-            <a:schemeClr val="accent1"/>
-          </a:fillRef>
-          <a:effectRef idx="0">
-            <a:schemeClr val="accent1"/>
-          </a:effectRef>
-          <a:fontRef idx="minor">
-            <a:schemeClr val="tx1"/>
-          </a:fontRef>
-        </p:style>
-      </p:cxnSp>
-      <p:cxnSp>
-        <p:nvCxnSpPr>
-          <p:cNvPr id="94" name="Connector: Elbow 93">
-            <a:extLst>
-              <a:ext uri="{FF2B5EF4-FFF2-40B4-BE49-F238E27FC236}">
-                <a16:creationId xmlns:a16="http://schemas.microsoft.com/office/drawing/2014/main" id="{D6A0A3DA-31D6-8044-7A2D-2044CAF0B5C5}"/>
-              </a:ext>
-            </a:extLst>
-          </p:cNvPr>
-          <p:cNvCxnSpPr>
-            <a:stCxn id="17" idx="2"/>
-            <a:endCxn id="10" idx="0"/>
-          </p:cNvCxnSpPr>
-          <p:nvPr/>
-        </p:nvCxnSpPr>
-        <p:spPr>
-          <a:xfrm rot="5400000">
-            <a:off x="1037006" y="1761978"/>
-            <a:ext cx="408165" cy="928"/>
-          </a:xfrm>
-          <a:prstGeom prst="bentConnector3">
-            <a:avLst/>
-          </a:prstGeom>
-          <a:ln>
-            <a:tailEnd type="triangle"/>
-          </a:ln>
-        </p:spPr>
-        <p:style>
-          <a:lnRef idx="1">
-            <a:schemeClr val="accent1"/>
-          </a:lnRef>
-          <a:fillRef idx="0">
-            <a:schemeClr val="accent1"/>
-          </a:fillRef>
-          <a:effectRef idx="0">
-            <a:schemeClr val="accent1"/>
-          </a:effectRef>
-          <a:fontRef idx="minor">
-            <a:schemeClr val="tx1"/>
-          </a:fontRef>
-        </p:style>
-      </p:cxnSp>
-      <p:cxnSp>
-        <p:nvCxnSpPr>
-          <p:cNvPr id="96" name="Connector: Elbow 95">
-            <a:extLst>
-              <a:ext uri="{FF2B5EF4-FFF2-40B4-BE49-F238E27FC236}">
-                <a16:creationId xmlns:a16="http://schemas.microsoft.com/office/drawing/2014/main" id="{CC33A512-4135-9EF5-D547-D7F9D7D7AE94}"/>
-              </a:ext>
-            </a:extLst>
-          </p:cNvPr>
-          <p:cNvCxnSpPr>
-            <a:stCxn id="12" idx="2"/>
-            <a:endCxn id="8" idx="0"/>
-          </p:cNvCxnSpPr>
-          <p:nvPr/>
-        </p:nvCxnSpPr>
-        <p:spPr>
-          <a:xfrm rot="5400000">
-            <a:off x="3019940" y="1776261"/>
-            <a:ext cx="379717" cy="508"/>
-          </a:xfrm>
-          <a:prstGeom prst="bentConnector3">
             <a:avLst/>
           </a:prstGeom>
           <a:ln>
@@ -2759,6 +2248,7 @@
             </a:extLst>
           </p:cNvPr>
           <p:cNvCxnSpPr>
+            <a:cxnSpLocks/>
             <a:stCxn id="22" idx="1"/>
             <a:endCxn id="30" idx="3"/>
           </p:cNvCxnSpPr>
@@ -2766,8 +2256,8 @@
         </p:nvCxnSpPr>
         <p:spPr>
           <a:xfrm flipH="1">
-            <a:off x="1798408" y="2766350"/>
-            <a:ext cx="743116" cy="2702"/>
+            <a:off x="1722208" y="2870259"/>
+            <a:ext cx="633388" cy="2702"/>
           </a:xfrm>
           <a:prstGeom prst="straightConnector1">
             <a:avLst/>
@@ -2815,8 +2305,8 @@
         </p:nvCxnSpPr>
         <p:spPr>
           <a:xfrm flipH="1">
-            <a:off x="3867404" y="2760814"/>
-            <a:ext cx="1871195" cy="5536"/>
+            <a:off x="3681476" y="2868397"/>
+            <a:ext cx="1719763" cy="1862"/>
           </a:xfrm>
           <a:prstGeom prst="straightConnector1">
             <a:avLst/>
@@ -2857,15 +2347,14 @@
           </p:cNvPr>
           <p:cNvCxnSpPr>
             <a:cxnSpLocks/>
-            <a:stCxn id="45" idx="2"/>
             <a:endCxn id="51" idx="0"/>
           </p:cNvCxnSpPr>
           <p:nvPr/>
         </p:nvCxnSpPr>
         <p:spPr>
-          <a:xfrm flipH="1">
-            <a:off x="6378679" y="1647688"/>
-            <a:ext cx="11637" cy="690216"/>
+          <a:xfrm>
+            <a:off x="6041319" y="1676813"/>
+            <a:ext cx="0" cy="697808"/>
           </a:xfrm>
           <a:prstGeom prst="straightConnector1">
             <a:avLst/>
@@ -2906,9 +2395,9 @@
           <p:nvPr/>
         </p:nvCxnSpPr>
         <p:spPr>
-          <a:xfrm>
-            <a:off x="7030396" y="1180150"/>
-            <a:ext cx="476919" cy="0"/>
+          <a:xfrm flipV="1">
+            <a:off x="7234857" y="1187077"/>
+            <a:ext cx="369437" cy="727"/>
           </a:xfrm>
           <a:prstGeom prst="straightConnector1">
             <a:avLst/>
@@ -2942,6 +2431,7 @@
             </a:extLst>
           </p:cNvPr>
           <p:cNvCxnSpPr>
+            <a:cxnSpLocks/>
             <a:stCxn id="61" idx="1"/>
             <a:endCxn id="51" idx="3"/>
           </p:cNvCxnSpPr>
@@ -2949,8 +2439,8 @@
         </p:nvCxnSpPr>
         <p:spPr>
           <a:xfrm flipH="1">
-            <a:off x="7018759" y="2757561"/>
-            <a:ext cx="552473" cy="3253"/>
+            <a:off x="6681399" y="2868397"/>
+            <a:ext cx="384693" cy="0"/>
           </a:xfrm>
           <a:prstGeom prst="straightConnector1">
             <a:avLst/>
@@ -2990,6 +2480,13 @@
         </p:nvPicPr>
         <p:blipFill>
           <a:blip r:embed="rId3">
+            <a:duotone>
+              <a:schemeClr val="accent3">
+                <a:shade val="45000"/>
+                <a:satMod val="135000"/>
+              </a:schemeClr>
+              <a:prstClr val="white"/>
+            </a:duotone>
             <a:extLst>
               <a:ext uri="{28A0092B-C50C-407E-A947-70E740481C1C}">
                 <a14:useLocalDpi xmlns:a14="http://schemas.microsoft.com/office/drawing/2010/main" val="0"/>
@@ -3003,7 +2500,7 @@
         </p:blipFill>
         <p:spPr bwMode="auto">
           <a:xfrm>
-            <a:off x="1059092" y="739834"/>
+            <a:off x="867068" y="739834"/>
             <a:ext cx="324743" cy="324743"/>
           </a:xfrm>
           <a:prstGeom prst="rect">
@@ -3050,7 +2547,7 @@
         </p:blipFill>
         <p:spPr bwMode="auto">
           <a:xfrm>
-            <a:off x="975636" y="3479870"/>
+            <a:off x="899436" y="3583779"/>
             <a:ext cx="456824" cy="337443"/>
           </a:xfrm>
           <a:prstGeom prst="rect">
@@ -3068,36 +2565,97 @@
           </a:extLst>
         </p:spPr>
       </p:pic>
-      <p:pic>
-        <p:nvPicPr>
-          <p:cNvPr id="125" name="Picture 124">
+      <p:grpSp>
+        <p:nvGrpSpPr>
+          <p:cNvPr id="66" name="Group 65">
             <a:extLst>
               <a:ext uri="{FF2B5EF4-FFF2-40B4-BE49-F238E27FC236}">
-                <a16:creationId xmlns:a16="http://schemas.microsoft.com/office/drawing/2014/main" id="{8E5C22EE-E613-9C21-820B-1887AEEB32A0}"/>
+                <a16:creationId xmlns:a16="http://schemas.microsoft.com/office/drawing/2014/main" id="{3BDE132F-766B-2D28-AEA6-29ACF56A0478}"/>
               </a:ext>
             </a:extLst>
           </p:cNvPr>
-          <p:cNvPicPr>
-            <a:picLocks noChangeAspect="1"/>
-          </p:cNvPicPr>
-          <p:nvPr/>
-        </p:nvPicPr>
-        <p:blipFill>
-          <a:blip r:embed="rId5"/>
-          <a:stretch>
-            <a:fillRect/>
-          </a:stretch>
-        </p:blipFill>
-        <p:spPr>
-          <a:xfrm>
-            <a:off x="1059092" y="-52953"/>
-            <a:ext cx="418302" cy="418302"/>
-          </a:xfrm>
-          <a:prstGeom prst="rect">
-            <a:avLst/>
-          </a:prstGeom>
-        </p:spPr>
-      </p:pic>
+          <p:cNvGrpSpPr/>
+          <p:nvPr/>
+        </p:nvGrpSpPr>
+        <p:grpSpPr>
+          <a:xfrm>
+            <a:off x="1250155" y="32419"/>
+            <a:ext cx="1865950" cy="310896"/>
+            <a:chOff x="1079181" y="32419"/>
+            <a:chExt cx="1865950" cy="310896"/>
+          </a:xfrm>
+        </p:grpSpPr>
+        <p:sp>
+          <p:nvSpPr>
+            <p:cNvPr id="2" name="Text 0"/>
+            <p:cNvSpPr/>
+            <p:nvPr/>
+          </p:nvSpPr>
+          <p:spPr>
+            <a:xfrm>
+              <a:off x="1432461" y="32419"/>
+              <a:ext cx="1512670" cy="310896"/>
+            </a:xfrm>
+            <a:prstGeom prst="rect">
+              <a:avLst/>
+            </a:prstGeom>
+            <a:noFill/>
+            <a:ln/>
+          </p:spPr>
+          <p:txBody>
+            <a:bodyPr wrap="square" lIns="0" tIns="0" rIns="0" bIns="0" rtlCol="0" anchor="ctr"/>
+            <a:lstStyle/>
+            <a:p>
+              <a:pPr marL="0" indent="0" algn="ctr">
+                <a:buNone/>
+              </a:pPr>
+              <a:r>
+                <a:rPr lang="es-CL" sz="1400" b="1" kern="0" spc="150" noProof="0" dirty="0">
+                  <a:solidFill>
+                    <a:srgbClr val="1F2A44"/>
+                  </a:solidFill>
+                  <a:latin typeface="Arial" pitchFamily="34" charset="0"/>
+                  <a:ea typeface="Arial" pitchFamily="34" charset="-122"/>
+                  <a:cs typeface="Arial" pitchFamily="34" charset="-120"/>
+                </a:rPr>
+                <a:t>ROBOT MÓVIL</a:t>
+              </a:r>
+              <a:endParaRPr lang="es-CL" sz="1400" noProof="0" dirty="0"/>
+            </a:p>
+          </p:txBody>
+        </p:sp>
+        <p:pic>
+          <p:nvPicPr>
+            <p:cNvPr id="125" name="Picture 124">
+              <a:extLst>
+                <a:ext uri="{FF2B5EF4-FFF2-40B4-BE49-F238E27FC236}">
+                  <a16:creationId xmlns:a16="http://schemas.microsoft.com/office/drawing/2014/main" id="{8E5C22EE-E613-9C21-820B-1887AEEB32A0}"/>
+                </a:ext>
+              </a:extLst>
+            </p:cNvPr>
+            <p:cNvPicPr>
+              <a:picLocks noChangeAspect="1"/>
+            </p:cNvPicPr>
+            <p:nvPr/>
+          </p:nvPicPr>
+          <p:blipFill>
+            <a:blip r:embed="rId5"/>
+            <a:srcRect t="2147"/>
+            <a:stretch>
+              <a:fillRect/>
+            </a:stretch>
+          </p:blipFill>
+          <p:spPr>
+            <a:xfrm>
+              <a:off x="1079181" y="32419"/>
+              <a:ext cx="317720" cy="310896"/>
+            </a:xfrm>
+            <a:prstGeom prst="rect">
+              <a:avLst/>
+            </a:prstGeom>
+          </p:spPr>
+        </p:pic>
+      </p:grpSp>
       <p:pic>
         <p:nvPicPr>
           <p:cNvPr id="127" name="Picture 126">
@@ -3120,7 +2678,7 @@
         </p:blipFill>
         <p:spPr>
           <a:xfrm>
-            <a:off x="3028895" y="792478"/>
+            <a:off x="2757623" y="792478"/>
             <a:ext cx="324159" cy="324159"/>
           </a:xfrm>
           <a:prstGeom prst="rect">
@@ -3150,7 +2708,7 @@
         </p:blipFill>
         <p:spPr>
           <a:xfrm>
-            <a:off x="1089335" y="2402395"/>
+            <a:off x="1013135" y="2506304"/>
             <a:ext cx="285813" cy="285813"/>
           </a:xfrm>
           <a:prstGeom prst="rect">
@@ -3180,7 +2738,7 @@
         </p:blipFill>
         <p:spPr>
           <a:xfrm>
-            <a:off x="3072360" y="2340938"/>
+            <a:off x="2886432" y="2444847"/>
             <a:ext cx="237227" cy="302893"/>
           </a:xfrm>
           <a:prstGeom prst="rect">
@@ -3210,7 +2768,7 @@
         </p:blipFill>
         <p:spPr>
           <a:xfrm>
-            <a:off x="7935959" y="745526"/>
+            <a:off x="8057891" y="750358"/>
             <a:ext cx="386296" cy="386296"/>
           </a:xfrm>
           <a:prstGeom prst="rect">
@@ -3240,7 +2798,7 @@
         </p:blipFill>
         <p:spPr>
           <a:xfrm>
-            <a:off x="6222352" y="2404501"/>
+            <a:off x="5884992" y="2515337"/>
             <a:ext cx="295980" cy="295980"/>
           </a:xfrm>
           <a:prstGeom prst="rect">
@@ -3248,6 +2806,365 @@
           </a:prstGeom>
         </p:spPr>
       </p:pic>
+      <p:pic>
+        <p:nvPicPr>
+          <p:cNvPr id="15" name="Picture 14">
+            <a:extLst>
+              <a:ext uri="{FF2B5EF4-FFF2-40B4-BE49-F238E27FC236}">
+                <a16:creationId xmlns:a16="http://schemas.microsoft.com/office/drawing/2014/main" id="{548CCD4D-315A-1091-2C53-BCBF7B3E4869}"/>
+              </a:ext>
+            </a:extLst>
+          </p:cNvPr>
+          <p:cNvPicPr>
+            <a:picLocks noChangeAspect="1"/>
+          </p:cNvPicPr>
+          <p:nvPr/>
+        </p:nvPicPr>
+        <p:blipFill>
+          <a:blip r:embed="rId11">
+            <a:duotone>
+              <a:srgbClr val="FFC000">
+                <a:shade val="45000"/>
+                <a:satMod val="135000"/>
+              </a:srgbClr>
+              <a:prstClr val="white"/>
+            </a:duotone>
+          </a:blip>
+          <a:srcRect l="23547" r="18730"/>
+          <a:stretch>
+            <a:fillRect/>
+          </a:stretch>
+        </p:blipFill>
+        <p:spPr>
+          <a:xfrm>
+            <a:off x="7194937" y="2458023"/>
+            <a:ext cx="477520" cy="827253"/>
+          </a:xfrm>
+          <a:prstGeom prst="rect">
+            <a:avLst/>
+          </a:prstGeom>
+        </p:spPr>
+      </p:pic>
+      <p:pic>
+        <p:nvPicPr>
+          <p:cNvPr id="31" name="Picture 30">
+            <a:extLst>
+              <a:ext uri="{FF2B5EF4-FFF2-40B4-BE49-F238E27FC236}">
+                <a16:creationId xmlns:a16="http://schemas.microsoft.com/office/drawing/2014/main" id="{0F39BD36-A346-8378-3186-0A573D93A959}"/>
+              </a:ext>
+            </a:extLst>
+          </p:cNvPr>
+          <p:cNvPicPr>
+            <a:picLocks noChangeAspect="1"/>
+          </p:cNvPicPr>
+          <p:nvPr/>
+        </p:nvPicPr>
+        <p:blipFill>
+          <a:blip r:embed="rId12">
+            <a:duotone>
+              <a:schemeClr val="accent4">
+                <a:shade val="45000"/>
+                <a:satMod val="135000"/>
+              </a:schemeClr>
+              <a:prstClr val="white"/>
+            </a:duotone>
+          </a:blip>
+          <a:srcRect l="8705" t="5335" r="10022" b="7441"/>
+          <a:stretch>
+            <a:fillRect/>
+          </a:stretch>
+        </p:blipFill>
+        <p:spPr>
+          <a:xfrm>
+            <a:off x="5490031" y="908955"/>
+            <a:ext cx="513996" cy="551625"/>
+          </a:xfrm>
+          <a:prstGeom prst="rect">
+            <a:avLst/>
+          </a:prstGeom>
+        </p:spPr>
+      </p:pic>
+      <p:grpSp>
+        <p:nvGrpSpPr>
+          <p:cNvPr id="59" name="Group 58">
+            <a:extLst>
+              <a:ext uri="{FF2B5EF4-FFF2-40B4-BE49-F238E27FC236}">
+                <a16:creationId xmlns:a16="http://schemas.microsoft.com/office/drawing/2014/main" id="{05B8F20D-FFB9-1551-13CC-BBE0B3E23652}"/>
+              </a:ext>
+            </a:extLst>
+          </p:cNvPr>
+          <p:cNvGrpSpPr/>
+          <p:nvPr/>
+        </p:nvGrpSpPr>
+        <p:grpSpPr>
+          <a:xfrm>
+            <a:off x="5601384" y="22177"/>
+            <a:ext cx="2996327" cy="314064"/>
+            <a:chOff x="5601384" y="22177"/>
+            <a:chExt cx="2996327" cy="314064"/>
+          </a:xfrm>
+        </p:grpSpPr>
+        <p:sp>
+          <p:nvSpPr>
+            <p:cNvPr id="3" name="Text 1"/>
+            <p:cNvSpPr/>
+            <p:nvPr/>
+          </p:nvSpPr>
+          <p:spPr>
+            <a:xfrm>
+              <a:off x="6004026" y="25345"/>
+              <a:ext cx="2593685" cy="310896"/>
+            </a:xfrm>
+            <a:prstGeom prst="rect">
+              <a:avLst/>
+            </a:prstGeom>
+            <a:noFill/>
+            <a:ln/>
+          </p:spPr>
+          <p:txBody>
+            <a:bodyPr wrap="square" lIns="0" tIns="0" rIns="0" bIns="0" rtlCol="0" anchor="ctr"/>
+            <a:lstStyle/>
+            <a:p>
+              <a:pPr marL="0" indent="0" algn="ctr">
+                <a:buNone/>
+              </a:pPr>
+              <a:r>
+                <a:rPr lang="es-CL" sz="1400" b="1" kern="0" spc="150" noProof="0" dirty="0">
+                  <a:solidFill>
+                    <a:srgbClr val="1F2A44"/>
+                  </a:solidFill>
+                  <a:latin typeface="Arial" pitchFamily="34" charset="0"/>
+                  <a:ea typeface="Arial" pitchFamily="34" charset="-122"/>
+                  <a:cs typeface="Arial" pitchFamily="34" charset="-120"/>
+                </a:rPr>
+                <a:t>ESTACIÓN DE TRABAJO</a:t>
+              </a:r>
+              <a:endParaRPr lang="es-CL" sz="1400" noProof="0" dirty="0"/>
+            </a:p>
+          </p:txBody>
+        </p:sp>
+        <p:pic>
+          <p:nvPicPr>
+            <p:cNvPr id="58" name="Picture 57">
+              <a:extLst>
+                <a:ext uri="{FF2B5EF4-FFF2-40B4-BE49-F238E27FC236}">
+                  <a16:creationId xmlns:a16="http://schemas.microsoft.com/office/drawing/2014/main" id="{3413F497-5EA1-F99A-BB4D-92CF0CDD4CB3}"/>
+                </a:ext>
+              </a:extLst>
+            </p:cNvPr>
+            <p:cNvPicPr>
+              <a:picLocks noChangeAspect="1"/>
+            </p:cNvPicPr>
+            <p:nvPr/>
+          </p:nvPicPr>
+          <p:blipFill>
+            <a:blip r:embed="rId13"/>
+            <a:stretch>
+              <a:fillRect/>
+            </a:stretch>
+          </p:blipFill>
+          <p:spPr>
+            <a:xfrm>
+              <a:off x="5601384" y="22177"/>
+              <a:ext cx="310896" cy="310896"/>
+            </a:xfrm>
+            <a:prstGeom prst="rect">
+              <a:avLst/>
+            </a:prstGeom>
+          </p:spPr>
+        </p:pic>
+      </p:grpSp>
+      <p:cxnSp>
+        <p:nvCxnSpPr>
+          <p:cNvPr id="85" name="Connector: Elbow 84">
+            <a:extLst>
+              <a:ext uri="{FF2B5EF4-FFF2-40B4-BE49-F238E27FC236}">
+                <a16:creationId xmlns:a16="http://schemas.microsoft.com/office/drawing/2014/main" id="{D488B783-AC2F-4DDA-E533-76B47CCAEA4A}"/>
+              </a:ext>
+            </a:extLst>
+          </p:cNvPr>
+          <p:cNvCxnSpPr>
+            <a:cxnSpLocks/>
+            <a:endCxn id="45" idx="1"/>
+          </p:cNvCxnSpPr>
+          <p:nvPr/>
+        </p:nvCxnSpPr>
+        <p:spPr>
+          <a:xfrm rot="5400000" flipH="1" flipV="1">
+            <a:off x="4140467" y="1633861"/>
+            <a:ext cx="1680315" cy="788202"/>
+          </a:xfrm>
+          <a:prstGeom prst="bentConnector2">
+            <a:avLst/>
+          </a:prstGeom>
+          <a:ln w="12700">
+            <a:tailEnd type="triangle" w="lg" len="med"/>
+          </a:ln>
+        </p:spPr>
+        <p:style>
+          <a:lnRef idx="1">
+            <a:schemeClr val="accent1"/>
+          </a:lnRef>
+          <a:fillRef idx="0">
+            <a:schemeClr val="accent1"/>
+          </a:fillRef>
+          <a:effectRef idx="0">
+            <a:schemeClr val="accent1"/>
+          </a:effectRef>
+          <a:fontRef idx="minor">
+            <a:schemeClr val="tx1"/>
+          </a:fontRef>
+        </p:style>
+      </p:cxnSp>
+      <p:sp>
+        <p:nvSpPr>
+          <p:cNvPr id="91" name="Rectangle: Rounded Corners 90">
+            <a:extLst>
+              <a:ext uri="{FF2B5EF4-FFF2-40B4-BE49-F238E27FC236}">
+                <a16:creationId xmlns:a16="http://schemas.microsoft.com/office/drawing/2014/main" id="{607B0FB9-9EB1-D809-CBFD-6DE6922420E6}"/>
+              </a:ext>
+            </a:extLst>
+          </p:cNvPr>
+          <p:cNvSpPr/>
+          <p:nvPr/>
+        </p:nvSpPr>
+        <p:spPr>
+          <a:xfrm>
+            <a:off x="4014463" y="2708757"/>
+            <a:ext cx="1144119" cy="318726"/>
+          </a:xfrm>
+          <a:prstGeom prst="roundRect">
+            <a:avLst/>
+          </a:prstGeom>
+          <a:solidFill>
+            <a:schemeClr val="bg1">
+              <a:lumMod val="95000"/>
+            </a:schemeClr>
+          </a:solidFill>
+          <a:ln>
+            <a:noFill/>
+          </a:ln>
+        </p:spPr>
+        <p:style>
+          <a:lnRef idx="2">
+            <a:schemeClr val="accent1">
+              <a:shade val="15000"/>
+            </a:schemeClr>
+          </a:lnRef>
+          <a:fillRef idx="1">
+            <a:schemeClr val="accent1"/>
+          </a:fillRef>
+          <a:effectRef idx="0">
+            <a:schemeClr val="accent1"/>
+          </a:effectRef>
+          <a:fontRef idx="minor">
+            <a:schemeClr val="lt1"/>
+          </a:fontRef>
+        </p:style>
+        <p:txBody>
+          <a:bodyPr rtlCol="0" anchor="ctr"/>
+          <a:lstStyle/>
+          <a:p>
+            <a:pPr algn="ctr"/>
+            <a:r>
+              <a:rPr lang="es-ES" sz="800" dirty="0">
+                <a:solidFill>
+                  <a:srgbClr val="39485C"/>
+                </a:solidFill>
+                <a:latin typeface="Arial" pitchFamily="34" charset="0"/>
+                <a:ea typeface="Arial" pitchFamily="34" charset="-122"/>
+                <a:cs typeface="Arial" pitchFamily="34" charset="-120"/>
+              </a:rPr>
+              <a:t>Intercambio de datos y comandos</a:t>
+            </a:r>
+            <a:endParaRPr lang="es-CL" sz="800" dirty="0"/>
+          </a:p>
+        </p:txBody>
+      </p:sp>
+      <p:cxnSp>
+        <p:nvCxnSpPr>
+          <p:cNvPr id="95" name="Straight Arrow Connector 94">
+            <a:extLst>
+              <a:ext uri="{FF2B5EF4-FFF2-40B4-BE49-F238E27FC236}">
+                <a16:creationId xmlns:a16="http://schemas.microsoft.com/office/drawing/2014/main" id="{4C454CB7-D494-CBBD-A5BF-8F357FD66ABD}"/>
+              </a:ext>
+            </a:extLst>
+          </p:cNvPr>
+          <p:cNvCxnSpPr>
+            <a:cxnSpLocks/>
+            <a:stCxn id="17" idx="2"/>
+          </p:cNvCxnSpPr>
+          <p:nvPr/>
+        </p:nvCxnSpPr>
+        <p:spPr>
+          <a:xfrm flipH="1">
+            <a:off x="1042391" y="1558360"/>
+            <a:ext cx="7137" cy="899663"/>
+          </a:xfrm>
+          <a:prstGeom prst="straightConnector1">
+            <a:avLst/>
+          </a:prstGeom>
+          <a:ln>
+            <a:tailEnd type="triangle"/>
+          </a:ln>
+        </p:spPr>
+        <p:style>
+          <a:lnRef idx="1">
+            <a:schemeClr val="accent1"/>
+          </a:lnRef>
+          <a:fillRef idx="0">
+            <a:schemeClr val="accent1"/>
+          </a:fillRef>
+          <a:effectRef idx="0">
+            <a:schemeClr val="accent1"/>
+          </a:effectRef>
+          <a:fontRef idx="minor">
+            <a:schemeClr val="tx1"/>
+          </a:fontRef>
+        </p:style>
+      </p:cxnSp>
+      <p:cxnSp>
+        <p:nvCxnSpPr>
+          <p:cNvPr id="101" name="Straight Arrow Connector 100">
+            <a:extLst>
+              <a:ext uri="{FF2B5EF4-FFF2-40B4-BE49-F238E27FC236}">
+                <a16:creationId xmlns:a16="http://schemas.microsoft.com/office/drawing/2014/main" id="{625EEC28-2477-2CE3-812E-90D59C367A0E}"/>
+              </a:ext>
+            </a:extLst>
+          </p:cNvPr>
+          <p:cNvCxnSpPr>
+            <a:cxnSpLocks/>
+            <a:stCxn id="12" idx="2"/>
+          </p:cNvCxnSpPr>
+          <p:nvPr/>
+        </p:nvCxnSpPr>
+        <p:spPr>
+          <a:xfrm>
+            <a:off x="2938780" y="1586657"/>
+            <a:ext cx="0" cy="803665"/>
+          </a:xfrm>
+          <a:prstGeom prst="straightConnector1">
+            <a:avLst/>
+          </a:prstGeom>
+          <a:ln>
+            <a:tailEnd type="triangle"/>
+          </a:ln>
+        </p:spPr>
+        <p:style>
+          <a:lnRef idx="1">
+            <a:schemeClr val="accent1"/>
+          </a:lnRef>
+          <a:fillRef idx="0">
+            <a:schemeClr val="accent1"/>
+          </a:fillRef>
+          <a:effectRef idx="0">
+            <a:schemeClr val="accent1"/>
+          </a:effectRef>
+          <a:fontRef idx="minor">
+            <a:schemeClr val="tx1"/>
+          </a:fontRef>
+        </p:style>
+      </p:cxnSp>
     </p:spTree>
   </p:cSld>
   <p:clrMapOvr>

</xml_diff>